<commit_message>
Add the new files
</commit_message>
<xml_diff>
--- a/Traffic_Crash_Analytics.pptx
+++ b/Traffic_Crash_Analytics.pptx
@@ -5,7 +5,7 @@
     <p:sldMasterId id="2147483743" r:id="rId1"/>
   </p:sldMasterIdLst>
   <p:notesMasterIdLst>
-    <p:notesMasterId r:id="rId12"/>
+    <p:notesMasterId r:id="rId13"/>
   </p:notesMasterIdLst>
   <p:sldIdLst>
     <p:sldId id="256" r:id="rId2"/>
@@ -18,6 +18,7 @@
     <p:sldId id="263" r:id="rId9"/>
     <p:sldId id="270" r:id="rId10"/>
     <p:sldId id="267" r:id="rId11"/>
+    <p:sldId id="271" r:id="rId12"/>
   </p:sldIdLst>
   <p:sldSz cx="9144000" cy="6858000" type="screen4x3"/>
   <p:notesSz cx="6858000" cy="9144000"/>
@@ -217,7 +218,7 @@
           <a:p>
             <a:fld id="{32D445F8-D683-42B5-9B92-2A7270774888}" type="datetimeFigureOut">
               <a:rPr lang="en-IN" smtClean="0"/>
-              <a:t>07-06-2026</a:t>
+              <a:t>09-06-2026</a:t>
             </a:fld>
             <a:endParaRPr lang="en-IN"/>
           </a:p>
@@ -645,6 +646,13 @@
               <a:noFill/>
             </a:ln>
           </p:spPr>
+          <p:txBody>
+            <a:bodyPr/>
+            <a:lstStyle/>
+            <a:p>
+              <a:endParaRPr lang="en-IN"/>
+            </a:p>
+          </p:txBody>
         </p:sp>
         <p:sp>
           <p:nvSpPr>
@@ -694,6 +702,13 @@
               <a:noFill/>
             </a:ln>
           </p:spPr>
+          <p:txBody>
+            <a:bodyPr/>
+            <a:lstStyle/>
+            <a:p>
+              <a:endParaRPr lang="en-IN"/>
+            </a:p>
+          </p:txBody>
         </p:sp>
         <p:sp>
           <p:nvSpPr>
@@ -740,6 +755,13 @@
               <a:noFill/>
             </a:ln>
           </p:spPr>
+          <p:txBody>
+            <a:bodyPr/>
+            <a:lstStyle/>
+            <a:p>
+              <a:endParaRPr lang="en-IN"/>
+            </a:p>
+          </p:txBody>
         </p:sp>
         <p:sp>
           <p:nvSpPr>
@@ -785,6 +807,13 @@
               <a:noFill/>
             </a:ln>
           </p:spPr>
+          <p:txBody>
+            <a:bodyPr/>
+            <a:lstStyle/>
+            <a:p>
+              <a:endParaRPr lang="en-IN"/>
+            </a:p>
+          </p:txBody>
         </p:sp>
         <p:sp>
           <p:nvSpPr>
@@ -836,6 +865,13 @@
               <a:noFill/>
             </a:ln>
           </p:spPr>
+          <p:txBody>
+            <a:bodyPr/>
+            <a:lstStyle/>
+            <a:p>
+              <a:endParaRPr lang="en-IN"/>
+            </a:p>
+          </p:txBody>
         </p:sp>
         <p:sp>
           <p:nvSpPr>
@@ -906,6 +942,13 @@
               <a:noFill/>
             </a:ln>
           </p:spPr>
+          <p:txBody>
+            <a:bodyPr/>
+            <a:lstStyle/>
+            <a:p>
+              <a:endParaRPr lang="en-IN"/>
+            </a:p>
+          </p:txBody>
         </p:sp>
       </p:grpSp>
       <p:sp>
@@ -1085,7 +1128,7 @@
           <a:p>
             <a:fld id="{5BCAD085-E8A6-8845-BD4E-CB4CCA059FC4}" type="datetimeFigureOut">
               <a:rPr lang="en-US" smtClean="0"/>
-              <a:t>6/7/2026</a:t>
+              <a:t>6/9/2026</a:t>
             </a:fld>
             <a:endParaRPr lang="en-US"/>
           </a:p>
@@ -1197,6 +1240,13 @@
             </a:ext>
           </a:extLst>
         </p:spPr>
+        <p:txBody>
+          <a:bodyPr/>
+          <a:lstStyle/>
+          <a:p>
+            <a:endParaRPr lang="en-IN"/>
+          </a:p>
+        </p:txBody>
       </p:sp>
       <p:sp>
         <p:nvSpPr>
@@ -1252,6 +1302,13 @@
             </a:ext>
           </a:extLst>
         </p:spPr>
+        <p:txBody>
+          <a:bodyPr/>
+          <a:lstStyle/>
+          <a:p>
+            <a:endParaRPr lang="en-IN"/>
+          </a:p>
+        </p:txBody>
       </p:sp>
     </p:spTree>
     <p:extLst>
@@ -1496,7 +1553,7 @@
           <a:p>
             <a:fld id="{5BCAD085-E8A6-8845-BD4E-CB4CCA059FC4}" type="datetimeFigureOut">
               <a:rPr lang="en-US" smtClean="0"/>
-              <a:t>6/7/2026</a:t>
+              <a:t>6/9/2026</a:t>
             </a:fld>
             <a:endParaRPr lang="en-US"/>
           </a:p>
@@ -1744,7 +1801,7 @@
           <a:p>
             <a:fld id="{5BCAD085-E8A6-8845-BD4E-CB4CCA059FC4}" type="datetimeFigureOut">
               <a:rPr lang="en-US" smtClean="0"/>
-              <a:t>6/7/2026</a:t>
+              <a:t>6/9/2026</a:t>
             </a:fld>
             <a:endParaRPr lang="en-US"/>
           </a:p>
@@ -2284,7 +2341,7 @@
           <a:p>
             <a:fld id="{5BCAD085-E8A6-8845-BD4E-CB4CCA059FC4}" type="datetimeFigureOut">
               <a:rPr lang="en-US" smtClean="0"/>
-              <a:t>6/7/2026</a:t>
+              <a:t>6/9/2026</a:t>
             </a:fld>
             <a:endParaRPr lang="en-US"/>
           </a:p>
@@ -2532,7 +2589,7 @@
           <a:p>
             <a:fld id="{5BCAD085-E8A6-8845-BD4E-CB4CCA059FC4}" type="datetimeFigureOut">
               <a:rPr lang="en-US" smtClean="0"/>
-              <a:t>6/7/2026</a:t>
+              <a:t>6/9/2026</a:t>
             </a:fld>
             <a:endParaRPr lang="en-US"/>
           </a:p>
@@ -3064,7 +3121,7 @@
           <a:p>
             <a:fld id="{5BCAD085-E8A6-8845-BD4E-CB4CCA059FC4}" type="datetimeFigureOut">
               <a:rPr lang="en-US" smtClean="0"/>
-              <a:t>6/7/2026</a:t>
+              <a:t>6/9/2026</a:t>
             </a:fld>
             <a:endParaRPr lang="en-US"/>
           </a:p>
@@ -3361,7 +3418,7 @@
           <a:p>
             <a:fld id="{5BCAD085-E8A6-8845-BD4E-CB4CCA059FC4}" type="datetimeFigureOut">
               <a:rPr lang="en-US" smtClean="0"/>
-              <a:t>6/7/2026</a:t>
+              <a:t>6/9/2026</a:t>
             </a:fld>
             <a:endParaRPr lang="en-US"/>
           </a:p>
@@ -3535,7 +3592,7 @@
           <a:p>
             <a:fld id="{5BCAD085-E8A6-8845-BD4E-CB4CCA059FC4}" type="datetimeFigureOut">
               <a:rPr lang="en-US" smtClean="0"/>
-              <a:t>6/7/2026</a:t>
+              <a:t>6/9/2026</a:t>
             </a:fld>
             <a:endParaRPr lang="en-US"/>
           </a:p>
@@ -3715,7 +3772,7 @@
           <a:p>
             <a:fld id="{5BCAD085-E8A6-8845-BD4E-CB4CCA059FC4}" type="datetimeFigureOut">
               <a:rPr lang="en-US" smtClean="0"/>
-              <a:t>6/7/2026</a:t>
+              <a:t>6/9/2026</a:t>
             </a:fld>
             <a:endParaRPr lang="en-US"/>
           </a:p>
@@ -3900,7 +3957,7 @@
           <a:p>
             <a:fld id="{5BCAD085-E8A6-8845-BD4E-CB4CCA059FC4}" type="datetimeFigureOut">
               <a:rPr lang="en-US" smtClean="0"/>
-              <a:t>6/7/2026</a:t>
+              <a:t>6/9/2026</a:t>
             </a:fld>
             <a:endParaRPr lang="en-US"/>
           </a:p>
@@ -4156,7 +4213,7 @@
           <a:p>
             <a:fld id="{5BCAD085-E8A6-8845-BD4E-CB4CCA059FC4}" type="datetimeFigureOut">
               <a:rPr lang="en-US" smtClean="0"/>
-              <a:t>6/7/2026</a:t>
+              <a:t>6/9/2026</a:t>
             </a:fld>
             <a:endParaRPr lang="en-US"/>
           </a:p>
@@ -4458,7 +4515,7 @@
           <a:p>
             <a:fld id="{5BCAD085-E8A6-8845-BD4E-CB4CCA059FC4}" type="datetimeFigureOut">
               <a:rPr lang="en-US" smtClean="0"/>
-              <a:t>6/7/2026</a:t>
+              <a:t>6/9/2026</a:t>
             </a:fld>
             <a:endParaRPr lang="en-US"/>
           </a:p>
@@ -4900,7 +4957,7 @@
           <a:p>
             <a:fld id="{5BCAD085-E8A6-8845-BD4E-CB4CCA059FC4}" type="datetimeFigureOut">
               <a:rPr lang="en-US" smtClean="0"/>
-              <a:t>6/7/2026</a:t>
+              <a:t>6/9/2026</a:t>
             </a:fld>
             <a:endParaRPr lang="en-US"/>
           </a:p>
@@ -5018,7 +5075,7 @@
           <a:p>
             <a:fld id="{5BCAD085-E8A6-8845-BD4E-CB4CCA059FC4}" type="datetimeFigureOut">
               <a:rPr lang="en-US" smtClean="0"/>
-              <a:t>6/7/2026</a:t>
+              <a:t>6/9/2026</a:t>
             </a:fld>
             <a:endParaRPr lang="en-US"/>
           </a:p>
@@ -5113,7 +5170,7 @@
           <a:p>
             <a:fld id="{5BCAD085-E8A6-8845-BD4E-CB4CCA059FC4}" type="datetimeFigureOut">
               <a:rPr lang="en-US" smtClean="0"/>
-              <a:t>6/7/2026</a:t>
+              <a:t>6/9/2026</a:t>
             </a:fld>
             <a:endParaRPr lang="en-US"/>
           </a:p>
@@ -5396,7 +5453,7 @@
           <a:p>
             <a:fld id="{5BCAD085-E8A6-8845-BD4E-CB4CCA059FC4}" type="datetimeFigureOut">
               <a:rPr lang="en-US" smtClean="0"/>
-              <a:t>6/7/2026</a:t>
+              <a:t>6/9/2026</a:t>
             </a:fld>
             <a:endParaRPr lang="en-US"/>
           </a:p>
@@ -5687,7 +5744,7 @@
           <a:p>
             <a:fld id="{5BCAD085-E8A6-8845-BD4E-CB4CCA059FC4}" type="datetimeFigureOut">
               <a:rPr lang="en-US" smtClean="0"/>
-              <a:t>6/7/2026</a:t>
+              <a:t>6/9/2026</a:t>
             </a:fld>
             <a:endParaRPr lang="en-US"/>
           </a:p>
@@ -5832,6 +5889,13 @@
               <a:noFill/>
             </a:ln>
           </p:spPr>
+          <p:txBody>
+            <a:bodyPr/>
+            <a:lstStyle/>
+            <a:p>
+              <a:endParaRPr lang="en-IN"/>
+            </a:p>
+          </p:txBody>
         </p:sp>
         <p:sp>
           <p:nvSpPr>
@@ -5881,6 +5945,13 @@
               <a:noFill/>
             </a:ln>
           </p:spPr>
+          <p:txBody>
+            <a:bodyPr/>
+            <a:lstStyle/>
+            <a:p>
+              <a:endParaRPr lang="en-IN"/>
+            </a:p>
+          </p:txBody>
         </p:sp>
         <p:sp>
           <p:nvSpPr>
@@ -5930,6 +6001,13 @@
               <a:noFill/>
             </a:ln>
           </p:spPr>
+          <p:txBody>
+            <a:bodyPr/>
+            <a:lstStyle/>
+            <a:p>
+              <a:endParaRPr lang="en-IN"/>
+            </a:p>
+          </p:txBody>
         </p:sp>
         <p:sp>
           <p:nvSpPr>
@@ -5978,6 +6056,13 @@
               <a:noFill/>
             </a:ln>
           </p:spPr>
+          <p:txBody>
+            <a:bodyPr/>
+            <a:lstStyle/>
+            <a:p>
+              <a:endParaRPr lang="en-IN"/>
+            </a:p>
+          </p:txBody>
         </p:sp>
         <p:sp>
           <p:nvSpPr>
@@ -6029,6 +6114,13 @@
               <a:noFill/>
             </a:ln>
           </p:spPr>
+          <p:txBody>
+            <a:bodyPr/>
+            <a:lstStyle/>
+            <a:p>
+              <a:endParaRPr lang="en-IN"/>
+            </a:p>
+          </p:txBody>
         </p:sp>
         <p:sp>
           <p:nvSpPr>
@@ -6078,6 +6170,13 @@
               <a:noFill/>
             </a:ln>
           </p:spPr>
+          <p:txBody>
+            <a:bodyPr/>
+            <a:lstStyle/>
+            <a:p>
+              <a:endParaRPr lang="en-IN"/>
+            </a:p>
+          </p:txBody>
         </p:sp>
       </p:grpSp>
       <p:sp>
@@ -6211,7 +6310,7 @@
           <a:p>
             <a:fld id="{5BCAD085-E8A6-8845-BD4E-CB4CCA059FC4}" type="datetimeFigureOut">
               <a:rPr lang="en-US" smtClean="0"/>
-              <a:t>6/7/2026</a:t>
+              <a:t>6/9/2026</a:t>
             </a:fld>
             <a:endParaRPr lang="en-US"/>
           </a:p>
@@ -6812,7 +6911,7 @@
         </p:nvSpPr>
         <p:spPr>
           <a:xfrm>
-            <a:off x="2890837" y="4503906"/>
+            <a:off x="4572000" y="5258915"/>
             <a:ext cx="5529263" cy="1388892"/>
           </a:xfrm>
         </p:spPr>
@@ -6828,7 +6927,7 @@
                 <a:latin typeface="Times New Roman" panose="02020603050405020304" pitchFamily="18" charset="0"/>
                 <a:cs typeface="Times New Roman" panose="02020603050405020304" pitchFamily="18" charset="0"/>
               </a:rPr>
-              <a:t>Submitted By: Vignesh </a:t>
+              <a:t>Submitted By : Vignesh </a:t>
             </a:r>
             <a:r>
               <a:rPr lang="en-IN" dirty="0" err="1">
@@ -6849,17 +6948,7 @@
                 <a:latin typeface="Times New Roman" panose="02020603050405020304" pitchFamily="18" charset="0"/>
                 <a:cs typeface="Times New Roman" panose="02020603050405020304" pitchFamily="18" charset="0"/>
               </a:rPr>
-              <a:t>Batch Name : AIML-C-WD-E-B54</a:t>
-            </a:r>
-          </a:p>
-          <a:p>
-            <a:pPr algn="just"/>
-            <a:r>
-              <a:rPr lang="en-IN" dirty="0">
-                <a:latin typeface="Times New Roman" panose="02020603050405020304" pitchFamily="18" charset="0"/>
-                <a:cs typeface="Times New Roman" panose="02020603050405020304" pitchFamily="18" charset="0"/>
-              </a:rPr>
-              <a:t>Technologies: Python | SQLite | SQL | Pandas | </a:t>
+              <a:t>Technologies : Python | SQLite | </a:t>
             </a:r>
             <a:r>
               <a:rPr lang="en-IN" dirty="0" err="1">
@@ -7029,6 +7118,103 @@
         </p:txBody>
       </p:sp>
     </p:spTree>
+  </p:cSld>
+  <p:clrMapOvr>
+    <a:masterClrMapping/>
+  </p:clrMapOvr>
+</p:sld>
+</file>
+
+<file path=ppt/slides/slide11.xml><?xml version="1.0" encoding="utf-8"?>
+<p:sld xmlns:a="http://schemas.openxmlformats.org/drawingml/2006/main" xmlns:r="http://schemas.openxmlformats.org/officeDocument/2006/relationships" xmlns:p="http://schemas.openxmlformats.org/presentationml/2006/main">
+  <p:cSld>
+    <p:spTree>
+      <p:nvGrpSpPr>
+        <p:cNvPr id="1" name=""/>
+        <p:cNvGrpSpPr/>
+        <p:nvPr/>
+      </p:nvGrpSpPr>
+      <p:grpSpPr>
+        <a:xfrm>
+          <a:off x="0" y="0"/>
+          <a:ext cx="0" cy="0"/>
+          <a:chOff x="0" y="0"/>
+          <a:chExt cx="0" cy="0"/>
+        </a:xfrm>
+      </p:grpSpPr>
+      <p:sp>
+        <p:nvSpPr>
+          <p:cNvPr id="2" name="Title 1">
+            <a:extLst>
+              <a:ext uri="{FF2B5EF4-FFF2-40B4-BE49-F238E27FC236}">
+                <a16:creationId xmlns:a16="http://schemas.microsoft.com/office/drawing/2014/main" id="{FE301672-BDC8-C3FC-6AFE-E0BBE3AB8EB0}"/>
+              </a:ext>
+            </a:extLst>
+          </p:cNvPr>
+          <p:cNvSpPr>
+            <a:spLocks noGrp="1"/>
+          </p:cNvSpPr>
+          <p:nvPr>
+            <p:ph type="title"/>
+          </p:nvPr>
+        </p:nvSpPr>
+        <p:spPr>
+          <a:xfrm>
+            <a:off x="982133" y="457201"/>
+            <a:ext cx="7704667" cy="5800986"/>
+          </a:xfrm>
+        </p:spPr>
+        <p:txBody>
+          <a:bodyPr>
+            <a:normAutofit/>
+          </a:bodyPr>
+          <a:lstStyle/>
+          <a:p>
+            <a:r>
+              <a:rPr lang="en-US" sz="4900" b="1" dirty="0">
+                <a:latin typeface="Times New Roman" panose="02020603050405020304" pitchFamily="18" charset="0"/>
+                <a:cs typeface="Times New Roman" panose="02020603050405020304" pitchFamily="18" charset="0"/>
+              </a:rPr>
+              <a:t>THANK YOU</a:t>
+            </a:r>
+            <a:endParaRPr lang="en-IN" sz="4900" b="1" dirty="0">
+              <a:latin typeface="Times New Roman" panose="02020603050405020304" pitchFamily="18" charset="0"/>
+              <a:cs typeface="Times New Roman" panose="02020603050405020304" pitchFamily="18" charset="0"/>
+            </a:endParaRPr>
+          </a:p>
+        </p:txBody>
+      </p:sp>
+      <p:sp>
+        <p:nvSpPr>
+          <p:cNvPr id="3" name="Content Placeholder 2">
+            <a:extLst>
+              <a:ext uri="{FF2B5EF4-FFF2-40B4-BE49-F238E27FC236}">
+                <a16:creationId xmlns:a16="http://schemas.microsoft.com/office/drawing/2014/main" id="{C74952BD-E879-7390-6F2E-C87099D5DFC6}"/>
+              </a:ext>
+            </a:extLst>
+          </p:cNvPr>
+          <p:cNvSpPr>
+            <a:spLocks noGrp="1"/>
+          </p:cNvSpPr>
+          <p:nvPr>
+            <p:ph idx="1"/>
+          </p:nvPr>
+        </p:nvSpPr>
+        <p:spPr/>
+        <p:txBody>
+          <a:bodyPr/>
+          <a:lstStyle/>
+          <a:p>
+            <a:endParaRPr lang="en-IN" dirty="0"/>
+          </a:p>
+        </p:txBody>
+      </p:sp>
+    </p:spTree>
+    <p:extLst>
+      <p:ext uri="{BB962C8B-B14F-4D97-AF65-F5344CB8AC3E}">
+        <p14:creationId xmlns:p14="http://schemas.microsoft.com/office/powerpoint/2010/main" val="1427845115"/>
+      </p:ext>
+    </p:extLst>
   </p:cSld>
   <p:clrMapOvr>
     <a:masterClrMapping/>
@@ -7781,7 +7967,7 @@
                 <a:latin typeface="Times New Roman" panose="02020603050405020304" pitchFamily="18" charset="0"/>
                 <a:cs typeface="Times New Roman" panose="02020603050405020304" pitchFamily="18" charset="0"/>
               </a:rPr>
-              <a:t>GROUP BY()</a:t>
+              <a:t>GROUP BY() </a:t>
             </a:r>
           </a:p>
           <a:p>

</xml_diff>